<commit_message>
Rebrand slide deck content to VeritasESG; sync package-lock name
</commit_message>
<xml_diff>
--- a/public/presentations/VeritasESG_Sunumu.pptx
+++ b/public/presentations/VeritasESG_Sunumu.pptx
@@ -3250,7 +3250,7 @@
                 <a:latin typeface="Calibri"/>
                 <a:ea typeface="Calibri"/>
               </a:rPr>
-              <a:t>GOVERNANCEIQ</a:t>
+              <a:t>VERITASESG</a:t>
             </a:r>
             <a:endParaRPr lang="en-GB" sz="1600" b="0" u="none" strike="noStrike">
               <a:solidFill>
@@ -3726,7 +3726,7 @@
                 <a:latin typeface="Calibri"/>
                 <a:ea typeface="Calibri"/>
               </a:rPr>
-              <a:t>GovernanceIQ, güncel sürdürülebilirlik raporlama çerçevelerini kapsar.</a:t>
+              <a:t>VeritasESG, güncel sürdürülebilirlik raporlama çerçevelerini kapsar.</a:t>
             </a:r>
             <a:endParaRPr lang="en-GB" sz="1350" b="0" u="none" strike="noStrike">
               <a:solidFill>
@@ -5446,7 +5446,7 @@
                 <a:latin typeface="Calibri"/>
                 <a:ea typeface="Calibri"/>
               </a:rPr>
-              <a:t>NEDEN GOVERNANCEIQ</a:t>
+              <a:t>NEDEN VERITASESG</a:t>
             </a:r>
             <a:endParaRPr lang="en-GB" sz="1200" b="0" u="none" strike="noStrike">
               <a:solidFill>
@@ -8995,7 +8995,7 @@
                 <a:latin typeface="Cambria"/>
                 <a:ea typeface="Cambria"/>
               </a:rPr>
-              <a:t>GovernanceIQ, sürdürülebilirlik danışmanlıklarının dağınık, manuel ve riskli raporlama süreçlerini; hızlı, izlenebilir ve yapay zeka destekli tek bir platforma taşır. GRI'den TSRS'ye kadar tüm önemli çerçeveleri tek çatı altında toplar, paydaşları sürece dâhil eder ve verinin kontrolünü size bırakır.</a:t>
+              <a:t>VeritasESG, sürdürülebilirlik danışmanlıklarının dağınık, manuel ve riskli raporlama süreçlerini; hızlı, izlenebilir ve yapay zeka destekli tek bir platforma taşır. GRI'den TSRS'ye kadar tüm önemli çerçeveleri tek çatı altında toplar, paydaşları sürece dâhil eder ve verinin kontrolünü size bırakır.</a:t>
             </a:r>
             <a:endParaRPr lang="en-GB" sz="1900" b="0" u="none" strike="noStrike">
               <a:solidFill>
@@ -9160,7 +9160,7 @@
                 <a:latin typeface="Calibri"/>
                 <a:ea typeface="Calibri"/>
               </a:rPr>
-              <a:t>GOVERNANCEIQ</a:t>
+              <a:t>VERITASESG</a:t>
             </a:r>
             <a:endParaRPr lang="en-GB" sz="1400" b="0" u="none" strike="noStrike">
               <a:solidFill>
@@ -10173,7 +10173,7 @@
                 <a:latin typeface="Cambria"/>
                 <a:ea typeface="Cambria"/>
               </a:rPr>
-              <a:t>GovernanceIQ bu karmaşayı tek bir dijital iş akışına dönüştürür.</a:t>
+              <a:t>VeritasESG bu karmaşayı tek bir dijital iş akışına dönüştürür.</a:t>
             </a:r>
             <a:endParaRPr lang="en-GB" sz="1600" b="0" u="none" strike="noStrike">
               <a:solidFill>
@@ -10393,7 +10393,7 @@
                 <a:latin typeface="Calibri"/>
                 <a:ea typeface="Calibri"/>
               </a:rPr>
-              <a:t>GovernanceIQ, sürdürülebilirlik ve kurumsal yönetişim (ESG) raporlamasını uçtan uca yönetir; danışmanlık firmalarının birden çok müşterisini tek bir platformda yönetmesini sağlar.</a:t>
+              <a:t>VeritasESG, sürdürülebilirlik ve kurumsal yönetişim (ESG) raporlamasını uçtan uca yönetir; danışmanlık firmalarının birden çok müşterisini tek bir platformda yönetmesini sağlar.</a:t>
             </a:r>
             <a:endParaRPr lang="en-GB" sz="1450" b="0" u="none" strike="noStrike">
               <a:solidFill>

</xml_diff>